<commit_message>
Fold the video and social review into the site and the GTM decks.
Hold the SCORE intro to seven seconds and send viewers to the Scoreboard Handball form. Open LinkedIn and Instagram first, keep Slam Agent as a 2027 story, and add a social kit with avatar, cover, remake still, and first posts.

Co-authored-by: Peter-zhangcheng-github0688 <zhangcheng0688@users.noreply.github.com>
</commit_message>
<xml_diff>
--- a/gtm/SLAM.SYSTEMS_GTM_Plan_CN.pptx
+++ b/gtm/SLAM.SYSTEMS_GTM_Plan_CN.pptx
@@ -16,6 +16,7 @@
     <p:sldId id="264" r:id="rId15"/>
     <p:sldId id="265" r:id="rId16"/>
     <p:sldId id="266" r:id="rId17"/>
+    <p:sldId id="267" r:id="rId18"/>
   </p:sldIdLst>
   <p:sldSz cx="12191695" cy="6858000" type="screen4x3"/>
   <p:notesSz cx="6858000" cy="9144000"/>
@@ -3450,7 +3451,7 @@
                 <a:latin typeface="PingFang SC"/>
                 <a:ea typeface="PingFang SC"/>
               </a:rPr>
-              <a:t>11 页  ·  执行版  ·  2026.09</a:t>
+              <a:t>12 页  ·  执行版  ·  2026.09</a:t>
             </a:r>
           </a:p>
         </p:txBody>
@@ -4496,7 +4497,7 @@
                 <a:latin typeface="PingFang SC"/>
                 <a:ea typeface="PingFang SC"/>
               </a:rPr>
-              <a:t>10 / 11</a:t>
+              <a:t>10 / 12</a:t>
             </a:r>
           </a:p>
         </p:txBody>
@@ -4643,7 +4644,1090 @@
                 <a:latin typeface="PingFang SC"/>
                 <a:ea typeface="PingFang SC"/>
               </a:rPr>
-              <a:t>10  /  九十天必须交出来的东西</a:t>
+              <a:t>10  /  Slam Agent</a:t>
+            </a:r>
+          </a:p>
+        </p:txBody>
+      </p:sp>
+      <p:sp>
+        <p:nvSpPr>
+          <p:cNvPr id="4" name="TextBox 3"/>
+          <p:cNvSpPr txBox="1"/>
+          <p:nvPr/>
+        </p:nvSpPr>
+        <p:spPr>
+          <a:xfrm>
+            <a:off x="566928" y="420624"/>
+            <a:ext cx="11064240" cy="384048"/>
+          </a:xfrm>
+          <a:prstGeom prst="rect">
+            <a:avLst/>
+          </a:prstGeom>
+          <a:noFill/>
+        </p:spPr>
+        <p:txBody>
+          <a:bodyPr wrap="square" anchor="t"/>
+          <a:lstStyle/>
+          <a:p>
+            <a:pPr algn="l">
+              <a:spcBef>
+                <a:spcPts val="0"/>
+              </a:spcBef>
+              <a:spcAft>
+                <a:spcPts val="0"/>
+              </a:spcAft>
+            </a:pPr>
+            <a:r>
+              <a:rPr sz="2200" b="1">
+                <a:solidFill>
+                  <a:srgbClr val="111111"/>
+                </a:solidFill>
+                <a:latin typeface="PingFang SC"/>
+                <a:ea typeface="PingFang SC"/>
+              </a:rPr>
+              <a:t>今秋仍卖项目。Agent 是 2027 的差异化叙事，不是现在的交货清单。</a:t>
+            </a:r>
+          </a:p>
+        </p:txBody>
+      </p:sp>
+      <p:sp>
+        <p:nvSpPr>
+          <p:cNvPr id="5" name="Rectangle 4"/>
+          <p:cNvSpPr/>
+          <p:nvPr/>
+        </p:nvSpPr>
+        <p:spPr>
+          <a:xfrm>
+            <a:off x="566928" y="841248"/>
+            <a:ext cx="384048" cy="38100"/>
+          </a:xfrm>
+          <a:prstGeom prst="rect">
+            <a:avLst/>
+          </a:prstGeom>
+          <a:solidFill>
+            <a:srgbClr val="FF004E"/>
+          </a:solidFill>
+          <a:ln>
+            <a:noFill/>
+          </a:ln>
+          <a:effectLst/>
+        </p:spPr>
+        <p:style>
+          <a:lnRef idx="1">
+            <a:schemeClr val="accent1"/>
+          </a:lnRef>
+          <a:fillRef idx="3">
+            <a:schemeClr val="accent1"/>
+          </a:fillRef>
+          <a:effectRef idx="2">
+            <a:schemeClr val="accent1"/>
+          </a:effectRef>
+          <a:fontRef idx="minor">
+            <a:schemeClr val="lt1"/>
+          </a:fontRef>
+        </p:style>
+        <p:txBody>
+          <a:bodyPr rtlCol="0" anchor="ctr"/>
+          <a:lstStyle/>
+          <a:p>
+            <a:pPr algn="ctr"/>
+          </a:p>
+        </p:txBody>
+      </p:sp>
+      <p:sp>
+        <p:nvSpPr>
+          <p:cNvPr id="6" name="Rectangle 5"/>
+          <p:cNvSpPr/>
+          <p:nvPr/>
+        </p:nvSpPr>
+        <p:spPr>
+          <a:xfrm>
+            <a:off x="566928" y="1078992"/>
+            <a:ext cx="2670048" cy="4160520"/>
+          </a:xfrm>
+          <a:prstGeom prst="rect">
+            <a:avLst/>
+          </a:prstGeom>
+          <a:solidFill>
+            <a:srgbClr val="F6F6F5"/>
+          </a:solidFill>
+          <a:ln>
+            <a:noFill/>
+          </a:ln>
+          <a:effectLst/>
+        </p:spPr>
+        <p:style>
+          <a:lnRef idx="1">
+            <a:schemeClr val="accent1"/>
+          </a:lnRef>
+          <a:fillRef idx="3">
+            <a:schemeClr val="accent1"/>
+          </a:fillRef>
+          <a:effectRef idx="2">
+            <a:schemeClr val="accent1"/>
+          </a:effectRef>
+          <a:fontRef idx="minor">
+            <a:schemeClr val="lt1"/>
+          </a:fontRef>
+        </p:style>
+        <p:txBody>
+          <a:bodyPr rtlCol="0" anchor="ctr"/>
+          <a:lstStyle/>
+          <a:p>
+            <a:pPr algn="ctr"/>
+          </a:p>
+        </p:txBody>
+      </p:sp>
+      <p:sp>
+        <p:nvSpPr>
+          <p:cNvPr id="7" name="TextBox 6"/>
+          <p:cNvSpPr txBox="1"/>
+          <p:nvPr/>
+        </p:nvSpPr>
+        <p:spPr>
+          <a:xfrm>
+            <a:off x="713232" y="1225296"/>
+            <a:ext cx="2377440" cy="365760"/>
+          </a:xfrm>
+          <a:prstGeom prst="rect">
+            <a:avLst/>
+          </a:prstGeom>
+          <a:noFill/>
+        </p:spPr>
+        <p:txBody>
+          <a:bodyPr wrap="square" anchor="t"/>
+          <a:lstStyle/>
+          <a:p>
+            <a:pPr algn="l">
+              <a:spcBef>
+                <a:spcPts val="0"/>
+              </a:spcBef>
+              <a:spcAft>
+                <a:spcPts val="0"/>
+              </a:spcAft>
+            </a:pPr>
+            <a:r>
+              <a:rPr sz="1600" b="1">
+                <a:solidFill>
+                  <a:srgbClr val="FF004E"/>
+                </a:solidFill>
+                <a:latin typeface="PingFang SC"/>
+                <a:ea typeface="PingFang SC"/>
+              </a:rPr>
+              <a:t>定位升级</a:t>
+            </a:r>
+          </a:p>
+        </p:txBody>
+      </p:sp>
+      <p:sp>
+        <p:nvSpPr>
+          <p:cNvPr id="8" name="TextBox 7"/>
+          <p:cNvSpPr txBox="1"/>
+          <p:nvPr/>
+        </p:nvSpPr>
+        <p:spPr>
+          <a:xfrm>
+            <a:off x="713232" y="1664208"/>
+            <a:ext cx="2377440" cy="3383280"/>
+          </a:xfrm>
+          <a:prstGeom prst="rect">
+            <a:avLst/>
+          </a:prstGeom>
+          <a:noFill/>
+        </p:spPr>
+        <p:txBody>
+          <a:bodyPr wrap="square" anchor="t"/>
+          <a:lstStyle/>
+          <a:p>
+            <a:pPr algn="l">
+              <a:spcBef>
+                <a:spcPts val="0"/>
+              </a:spcBef>
+              <a:spcAft>
+                <a:spcPts val="0"/>
+              </a:spcAft>
+            </a:pPr>
+            <a:r>
+              <a:rPr sz="1300" b="0">
+                <a:solidFill>
+                  <a:srgbClr val="6B6B6B"/>
+                </a:solidFill>
+                <a:latin typeface="PingFang SC"/>
+                <a:ea typeface="PingFang SC"/>
+              </a:rPr>
+              <a:t>从「硬件 + 软件」讲成 Slam Agent：</a:t>
+            </a:r>
+          </a:p>
+          <a:p>
+            <a:pPr algn="l">
+              <a:spcBef>
+                <a:spcPts val="0"/>
+              </a:spcBef>
+              <a:spcAft>
+                <a:spcPts val="0"/>
+              </a:spcAft>
+            </a:pPr>
+            <a:r>
+              <a:rPr sz="1300" b="0">
+                <a:solidFill>
+                  <a:srgbClr val="6B6B6B"/>
+                </a:solidFill>
+                <a:latin typeface="PingFang SC"/>
+                <a:ea typeface="PingFang SC"/>
+              </a:rPr>
+              <a:t>一场比赛的智能代理，而不只是记分屏。</a:t>
+            </a:r>
+          </a:p>
+          <a:p>
+            <a:pPr algn="l">
+              <a:spcBef>
+                <a:spcPts val="0"/>
+              </a:spcBef>
+              <a:spcAft>
+                <a:spcPts val="0"/>
+              </a:spcAft>
+            </a:pPr>
+            <a:r>
+              <a:rPr sz="1300" b="0">
+                <a:solidFill>
+                  <a:srgbClr val="6B6B6B"/>
+                </a:solidFill>
+                <a:latin typeface="PingFang SC"/>
+                <a:ea typeface="PingFang SC"/>
+              </a:rPr>
+              <a:t>用来区别同质化记分/LED 竞品。</a:t>
+            </a:r>
+          </a:p>
+        </p:txBody>
+      </p:sp>
+      <p:sp>
+        <p:nvSpPr>
+          <p:cNvPr id="9" name="Rectangle 8"/>
+          <p:cNvSpPr/>
+          <p:nvPr/>
+        </p:nvSpPr>
+        <p:spPr>
+          <a:xfrm>
+            <a:off x="3383280" y="1078992"/>
+            <a:ext cx="2670048" cy="4160520"/>
+          </a:xfrm>
+          <a:prstGeom prst="rect">
+            <a:avLst/>
+          </a:prstGeom>
+          <a:solidFill>
+            <a:srgbClr val="F6F6F5"/>
+          </a:solidFill>
+          <a:ln>
+            <a:noFill/>
+          </a:ln>
+          <a:effectLst/>
+        </p:spPr>
+        <p:style>
+          <a:lnRef idx="1">
+            <a:schemeClr val="accent1"/>
+          </a:lnRef>
+          <a:fillRef idx="3">
+            <a:schemeClr val="accent1"/>
+          </a:fillRef>
+          <a:effectRef idx="2">
+            <a:schemeClr val="accent1"/>
+          </a:effectRef>
+          <a:fontRef idx="minor">
+            <a:schemeClr val="lt1"/>
+          </a:fontRef>
+        </p:style>
+        <p:txBody>
+          <a:bodyPr rtlCol="0" anchor="ctr"/>
+          <a:lstStyle/>
+          <a:p>
+            <a:pPr algn="ctr"/>
+          </a:p>
+        </p:txBody>
+      </p:sp>
+      <p:sp>
+        <p:nvSpPr>
+          <p:cNvPr id="10" name="TextBox 9"/>
+          <p:cNvSpPr txBox="1"/>
+          <p:nvPr/>
+        </p:nvSpPr>
+        <p:spPr>
+          <a:xfrm>
+            <a:off x="3529584" y="1225296"/>
+            <a:ext cx="2377440" cy="365760"/>
+          </a:xfrm>
+          <a:prstGeom prst="rect">
+            <a:avLst/>
+          </a:prstGeom>
+          <a:noFill/>
+        </p:spPr>
+        <p:txBody>
+          <a:bodyPr wrap="square" anchor="t"/>
+          <a:lstStyle/>
+          <a:p>
+            <a:pPr algn="l">
+              <a:spcBef>
+                <a:spcPts val="0"/>
+              </a:spcBef>
+              <a:spcAft>
+                <a:spcPts val="0"/>
+              </a:spcAft>
+            </a:pPr>
+            <a:r>
+              <a:rPr sz="1600" b="1">
+                <a:solidFill>
+                  <a:srgbClr val="FF004E"/>
+                </a:solidFill>
+                <a:latin typeface="PingFang SC"/>
+                <a:ea typeface="PingFang SC"/>
+              </a:rPr>
+              <a:t>技术路径</a:t>
+            </a:r>
+          </a:p>
+        </p:txBody>
+      </p:sp>
+      <p:sp>
+        <p:nvSpPr>
+          <p:cNvPr id="11" name="TextBox 10"/>
+          <p:cNvSpPr txBox="1"/>
+          <p:nvPr/>
+        </p:nvSpPr>
+        <p:spPr>
+          <a:xfrm>
+            <a:off x="3529584" y="1664208"/>
+            <a:ext cx="2377440" cy="3383280"/>
+          </a:xfrm>
+          <a:prstGeom prst="rect">
+            <a:avLst/>
+          </a:prstGeom>
+          <a:noFill/>
+        </p:spPr>
+        <p:txBody>
+          <a:bodyPr wrap="square" anchor="t"/>
+          <a:lstStyle/>
+          <a:p>
+            <a:pPr algn="l">
+              <a:spcBef>
+                <a:spcPts val="0"/>
+              </a:spcBef>
+              <a:spcAft>
+                <a:spcPts val="0"/>
+              </a:spcAft>
+            </a:pPr>
+            <a:r>
+              <a:rPr sz="1300" b="0">
+                <a:solidFill>
+                  <a:srgbClr val="6B6B6B"/>
+                </a:solidFill>
+                <a:latin typeface="PingFang SC"/>
+                <a:ea typeface="PingFang SC"/>
+              </a:rPr>
+              <a:t>开源 Linux 网关底座。</a:t>
+            </a:r>
+          </a:p>
+          <a:p>
+            <a:pPr algn="l">
+              <a:spcBef>
+                <a:spcPts val="0"/>
+              </a:spcBef>
+              <a:spcAft>
+                <a:spcPts val="0"/>
+              </a:spcAft>
+            </a:pPr>
+            <a:r>
+              <a:rPr sz="1300" b="0">
+                <a:solidFill>
+                  <a:srgbClr val="6B6B6B"/>
+                </a:solidFill>
+                <a:latin typeface="PingFang SC"/>
+                <a:ea typeface="PingFang SC"/>
+              </a:rPr>
+              <a:t>语音切灯光 / 广告方案。</a:t>
+            </a:r>
+          </a:p>
+          <a:p>
+            <a:pPr algn="l">
+              <a:spcBef>
+                <a:spcPts val="0"/>
+              </a:spcBef>
+              <a:spcAft>
+                <a:spcPts val="0"/>
+              </a:spcAft>
+            </a:pPr>
+            <a:r>
+              <a:rPr sz="1300" b="0">
+                <a:solidFill>
+                  <a:srgbClr val="6B6B6B"/>
+                </a:solidFill>
+                <a:latin typeface="PingFang SC"/>
+                <a:ea typeface="PingFang SC"/>
+              </a:rPr>
+              <a:t>自然语言交代「下一球暂停广告」。</a:t>
+            </a:r>
+          </a:p>
+          <a:p>
+            <a:pPr algn="l">
+              <a:spcBef>
+                <a:spcPts val="0"/>
+              </a:spcBef>
+              <a:spcAft>
+                <a:spcPts val="0"/>
+              </a:spcAft>
+            </a:pPr>
+            <a:r>
+              <a:rPr sz="1300" b="0">
+                <a:solidFill>
+                  <a:srgbClr val="6B6B6B"/>
+                </a:solidFill>
+                <a:latin typeface="PingFang SC"/>
+                <a:ea typeface="PingFang SC"/>
+              </a:rPr>
+              <a:t>能演示再写进官网，不能演示就先别写。</a:t>
+            </a:r>
+          </a:p>
+        </p:txBody>
+      </p:sp>
+      <p:sp>
+        <p:nvSpPr>
+          <p:cNvPr id="12" name="Rectangle 11"/>
+          <p:cNvSpPr/>
+          <p:nvPr/>
+        </p:nvSpPr>
+        <p:spPr>
+          <a:xfrm>
+            <a:off x="6199632" y="1078992"/>
+            <a:ext cx="2670048" cy="4160520"/>
+          </a:xfrm>
+          <a:prstGeom prst="rect">
+            <a:avLst/>
+          </a:prstGeom>
+          <a:solidFill>
+            <a:srgbClr val="F6F6F5"/>
+          </a:solidFill>
+          <a:ln>
+            <a:noFill/>
+          </a:ln>
+          <a:effectLst/>
+        </p:spPr>
+        <p:style>
+          <a:lnRef idx="1">
+            <a:schemeClr val="accent1"/>
+          </a:lnRef>
+          <a:fillRef idx="3">
+            <a:schemeClr val="accent1"/>
+          </a:fillRef>
+          <a:effectRef idx="2">
+            <a:schemeClr val="accent1"/>
+          </a:effectRef>
+          <a:fontRef idx="minor">
+            <a:schemeClr val="lt1"/>
+          </a:fontRef>
+        </p:style>
+        <p:txBody>
+          <a:bodyPr rtlCol="0" anchor="ctr"/>
+          <a:lstStyle/>
+          <a:p>
+            <a:pPr algn="ctr"/>
+          </a:p>
+        </p:txBody>
+      </p:sp>
+      <p:sp>
+        <p:nvSpPr>
+          <p:cNvPr id="13" name="TextBox 12"/>
+          <p:cNvSpPr txBox="1"/>
+          <p:nvPr/>
+        </p:nvSpPr>
+        <p:spPr>
+          <a:xfrm>
+            <a:off x="6345936" y="1225296"/>
+            <a:ext cx="2377440" cy="365760"/>
+          </a:xfrm>
+          <a:prstGeom prst="rect">
+            <a:avLst/>
+          </a:prstGeom>
+          <a:noFill/>
+        </p:spPr>
+        <p:txBody>
+          <a:bodyPr wrap="square" anchor="t"/>
+          <a:lstStyle/>
+          <a:p>
+            <a:pPr algn="l">
+              <a:spcBef>
+                <a:spcPts val="0"/>
+              </a:spcBef>
+              <a:spcAft>
+                <a:spcPts val="0"/>
+              </a:spcAft>
+            </a:pPr>
+            <a:r>
+              <a:rPr sz="1600" b="1">
+                <a:solidFill>
+                  <a:srgbClr val="FF004E"/>
+                </a:solidFill>
+                <a:latin typeface="PingFang SC"/>
+                <a:ea typeface="PingFang SC"/>
+              </a:rPr>
+              <a:t>场景互动</a:t>
+            </a:r>
+          </a:p>
+        </p:txBody>
+      </p:sp>
+      <p:sp>
+        <p:nvSpPr>
+          <p:cNvPr id="14" name="TextBox 13"/>
+          <p:cNvSpPr txBox="1"/>
+          <p:nvPr/>
+        </p:nvSpPr>
+        <p:spPr>
+          <a:xfrm>
+            <a:off x="6345936" y="1664208"/>
+            <a:ext cx="2377440" cy="3383280"/>
+          </a:xfrm>
+          <a:prstGeom prst="rect">
+            <a:avLst/>
+          </a:prstGeom>
+          <a:noFill/>
+        </p:spPr>
+        <p:txBody>
+          <a:bodyPr wrap="square" anchor="t"/>
+          <a:lstStyle/>
+          <a:p>
+            <a:pPr algn="l">
+              <a:spcBef>
+                <a:spcPts val="0"/>
+              </a:spcBef>
+              <a:spcAft>
+                <a:spcPts val="0"/>
+              </a:spcAft>
+            </a:pPr>
+            <a:r>
+              <a:rPr sz="1300" b="0">
+                <a:solidFill>
+                  <a:srgbClr val="6B6B6B"/>
+                </a:solidFill>
+                <a:latin typeface="PingFang SC"/>
+                <a:ea typeface="PingFang SC"/>
+              </a:rPr>
+              <a:t>现场氛围感知：掌声分贝触发灯光秀。</a:t>
+            </a:r>
+          </a:p>
+          <a:p>
+            <a:pPr algn="l">
+              <a:spcBef>
+                <a:spcPts val="0"/>
+              </a:spcBef>
+              <a:spcAft>
+                <a:spcPts val="0"/>
+              </a:spcAft>
+            </a:pPr>
+            <a:r>
+              <a:rPr sz="1300" b="0">
+                <a:solidFill>
+                  <a:srgbClr val="6B6B6B"/>
+                </a:solidFill>
+                <a:latin typeface="PingFang SC"/>
+                <a:ea typeface="PingFang SC"/>
+              </a:rPr>
+              <a:t>参考互动应用，不做粉丝玩具。</a:t>
+            </a:r>
+          </a:p>
+          <a:p>
+            <a:pPr algn="l">
+              <a:spcBef>
+                <a:spcPts val="0"/>
+              </a:spcBef>
+              <a:spcAft>
+                <a:spcPts val="0"/>
+              </a:spcAft>
+            </a:pPr>
+            <a:r>
+              <a:rPr sz="1300" b="0">
+                <a:solidFill>
+                  <a:srgbClr val="6B6B6B"/>
+                </a:solidFill>
+                <a:latin typeface="PingFang SC"/>
+                <a:ea typeface="PingFang SC"/>
+              </a:rPr>
+              <a:t>给集成商看「整场系统会自己反应」。</a:t>
+            </a:r>
+          </a:p>
+        </p:txBody>
+      </p:sp>
+      <p:sp>
+        <p:nvSpPr>
+          <p:cNvPr id="15" name="Rectangle 14"/>
+          <p:cNvSpPr/>
+          <p:nvPr/>
+        </p:nvSpPr>
+        <p:spPr>
+          <a:xfrm>
+            <a:off x="9015984" y="1078992"/>
+            <a:ext cx="2670048" cy="4160520"/>
+          </a:xfrm>
+          <a:prstGeom prst="rect">
+            <a:avLst/>
+          </a:prstGeom>
+          <a:solidFill>
+            <a:srgbClr val="F6F6F5"/>
+          </a:solidFill>
+          <a:ln>
+            <a:noFill/>
+          </a:ln>
+          <a:effectLst/>
+        </p:spPr>
+        <p:style>
+          <a:lnRef idx="1">
+            <a:schemeClr val="accent1"/>
+          </a:lnRef>
+          <a:fillRef idx="3">
+            <a:schemeClr val="accent1"/>
+          </a:fillRef>
+          <a:effectRef idx="2">
+            <a:schemeClr val="accent1"/>
+          </a:effectRef>
+          <a:fontRef idx="minor">
+            <a:schemeClr val="lt1"/>
+          </a:fontRef>
+        </p:style>
+        <p:txBody>
+          <a:bodyPr rtlCol="0" anchor="ctr"/>
+          <a:lstStyle/>
+          <a:p>
+            <a:pPr algn="ctr"/>
+          </a:p>
+        </p:txBody>
+      </p:sp>
+      <p:sp>
+        <p:nvSpPr>
+          <p:cNvPr id="16" name="TextBox 15"/>
+          <p:cNvSpPr txBox="1"/>
+          <p:nvPr/>
+        </p:nvSpPr>
+        <p:spPr>
+          <a:xfrm>
+            <a:off x="9162288" y="1225296"/>
+            <a:ext cx="2377440" cy="365760"/>
+          </a:xfrm>
+          <a:prstGeom prst="rect">
+            <a:avLst/>
+          </a:prstGeom>
+          <a:noFill/>
+        </p:spPr>
+        <p:txBody>
+          <a:bodyPr wrap="square" anchor="t"/>
+          <a:lstStyle/>
+          <a:p>
+            <a:pPr algn="l">
+              <a:spcBef>
+                <a:spcPts val="0"/>
+              </a:spcBef>
+              <a:spcAft>
+                <a:spcPts val="0"/>
+              </a:spcAft>
+            </a:pPr>
+            <a:r>
+              <a:rPr sz="1600" b="1">
+                <a:solidFill>
+                  <a:srgbClr val="FF004E"/>
+                </a:solidFill>
+                <a:latin typeface="PingFang SC"/>
+                <a:ea typeface="PingFang SC"/>
+              </a:rPr>
+              <a:t>需求入口</a:t>
+            </a:r>
+          </a:p>
+        </p:txBody>
+      </p:sp>
+      <p:sp>
+        <p:nvSpPr>
+          <p:cNvPr id="17" name="TextBox 16"/>
+          <p:cNvSpPr txBox="1"/>
+          <p:nvPr/>
+        </p:nvSpPr>
+        <p:spPr>
+          <a:xfrm>
+            <a:off x="9162288" y="1664208"/>
+            <a:ext cx="2377440" cy="3383280"/>
+          </a:xfrm>
+          <a:prstGeom prst="rect">
+            <a:avLst/>
+          </a:prstGeom>
+          <a:noFill/>
+        </p:spPr>
+        <p:txBody>
+          <a:bodyPr wrap="square" anchor="t"/>
+          <a:lstStyle/>
+          <a:p>
+            <a:pPr algn="l">
+              <a:spcBef>
+                <a:spcPts val="0"/>
+              </a:spcBef>
+              <a:spcAft>
+                <a:spcPts val="0"/>
+              </a:spcAft>
+            </a:pPr>
+            <a:r>
+              <a:rPr sz="1300" b="0">
+                <a:solidFill>
+                  <a:srgbClr val="6B6B6B"/>
+                </a:solidFill>
+                <a:latin typeface="PingFang SC"/>
+                <a:ea typeface="PingFang SC"/>
+              </a:rPr>
+              <a:t>Solutions 页加 Custom AI Solution。</a:t>
+            </a:r>
+          </a:p>
+          <a:p>
+            <a:pPr algn="l">
+              <a:spcBef>
+                <a:spcPts val="0"/>
+              </a:spcBef>
+              <a:spcAft>
+                <a:spcPts val="0"/>
+              </a:spcAft>
+            </a:pPr>
+            <a:r>
+              <a:rPr sz="1300" b="0">
+                <a:solidFill>
+                  <a:srgbClr val="6B6B6B"/>
+                </a:solidFill>
+                <a:latin typeface="PingFang SC"/>
+                <a:ea typeface="PingFang SC"/>
+              </a:rPr>
+              <a:t>请客户写下：自动统计、售票、灯光编排。</a:t>
+            </a:r>
+          </a:p>
+          <a:p>
+            <a:pPr algn="l">
+              <a:spcBef>
+                <a:spcPts val="0"/>
+              </a:spcBef>
+              <a:spcAft>
+                <a:spcPts val="0"/>
+              </a:spcAft>
+            </a:pPr>
+            <a:r>
+              <a:rPr sz="1300" b="0">
+                <a:solidFill>
+                  <a:srgbClr val="6B6B6B"/>
+                </a:solidFill>
+                <a:latin typeface="PingFang SC"/>
+                <a:ea typeface="PingFang SC"/>
+              </a:rPr>
+              <a:t>用来收集需求，不假装功能已经交付。</a:t>
+            </a:r>
+          </a:p>
+        </p:txBody>
+      </p:sp>
+      <p:sp>
+        <p:nvSpPr>
+          <p:cNvPr id="18" name="Rectangle 17"/>
+          <p:cNvSpPr/>
+          <p:nvPr/>
+        </p:nvSpPr>
+        <p:spPr>
+          <a:xfrm>
+            <a:off x="566928" y="5413248"/>
+            <a:ext cx="11045952" cy="896112"/>
+          </a:xfrm>
+          <a:prstGeom prst="rect">
+            <a:avLst/>
+          </a:prstGeom>
+          <a:solidFill>
+            <a:srgbClr val="111111"/>
+          </a:solidFill>
+          <a:ln>
+            <a:noFill/>
+          </a:ln>
+          <a:effectLst/>
+        </p:spPr>
+        <p:style>
+          <a:lnRef idx="1">
+            <a:schemeClr val="accent1"/>
+          </a:lnRef>
+          <a:fillRef idx="3">
+            <a:schemeClr val="accent1"/>
+          </a:fillRef>
+          <a:effectRef idx="2">
+            <a:schemeClr val="accent1"/>
+          </a:effectRef>
+          <a:fontRef idx="minor">
+            <a:schemeClr val="lt1"/>
+          </a:fontRef>
+        </p:style>
+        <p:txBody>
+          <a:bodyPr rtlCol="0" anchor="ctr"/>
+          <a:lstStyle/>
+          <a:p>
+            <a:pPr algn="ctr"/>
+          </a:p>
+        </p:txBody>
+      </p:sp>
+      <p:sp>
+        <p:nvSpPr>
+          <p:cNvPr id="19" name="TextBox 18"/>
+          <p:cNvSpPr txBox="1"/>
+          <p:nvPr/>
+        </p:nvSpPr>
+        <p:spPr>
+          <a:xfrm>
+            <a:off x="749808" y="5541264"/>
+            <a:ext cx="10698480" cy="658368"/>
+          </a:xfrm>
+          <a:prstGeom prst="rect">
+            <a:avLst/>
+          </a:prstGeom>
+          <a:noFill/>
+        </p:spPr>
+        <p:txBody>
+          <a:bodyPr wrap="square" anchor="ctr"/>
+          <a:lstStyle/>
+          <a:p>
+            <a:pPr algn="l">
+              <a:spcBef>
+                <a:spcPts val="0"/>
+              </a:spcBef>
+              <a:spcAft>
+                <a:spcPts val="0"/>
+              </a:spcAft>
+            </a:pPr>
+            <a:r>
+              <a:rPr sz="1400" b="0">
+                <a:solidFill>
+                  <a:srgbClr val="FFFFFF"/>
+                </a:solidFill>
+                <a:latin typeface="PingFang SC"/>
+                <a:ea typeface="PingFang SC"/>
+              </a:rPr>
+              <a:t>纪律：德文主站今秋主诉仍是一人操作系统 + SCORE / LED。Agent 只出现在简报、LinkedIn 和封闭活动，不替代现有产品名。</a:t>
+            </a:r>
+          </a:p>
+        </p:txBody>
+      </p:sp>
+      <p:sp>
+        <p:nvSpPr>
+          <p:cNvPr id="20" name="TextBox 19"/>
+          <p:cNvSpPr txBox="1"/>
+          <p:nvPr/>
+        </p:nvSpPr>
+        <p:spPr>
+          <a:xfrm>
+            <a:off x="566928" y="6565392"/>
+            <a:ext cx="7315200" cy="219456"/>
+          </a:xfrm>
+          <a:prstGeom prst="rect">
+            <a:avLst/>
+          </a:prstGeom>
+          <a:noFill/>
+        </p:spPr>
+        <p:txBody>
+          <a:bodyPr wrap="square" anchor="t"/>
+          <a:lstStyle/>
+          <a:p>
+            <a:pPr algn="l">
+              <a:spcBef>
+                <a:spcPts val="0"/>
+              </a:spcBef>
+              <a:spcAft>
+                <a:spcPts val="0"/>
+              </a:spcAft>
+            </a:pPr>
+            <a:r>
+              <a:rPr sz="1000" b="0">
+                <a:solidFill>
+                  <a:srgbClr val="6B6B6B"/>
+                </a:solidFill>
+                <a:latin typeface="PingFang SC"/>
+                <a:ea typeface="PingFang SC"/>
+              </a:rPr>
+              <a:t>SLAM.SYSTEMS  ·  GTM 2026 Q4 – 2027 Q1</a:t>
+            </a:r>
+          </a:p>
+        </p:txBody>
+      </p:sp>
+      <p:sp>
+        <p:nvSpPr>
+          <p:cNvPr id="21" name="TextBox 20"/>
+          <p:cNvSpPr txBox="1"/>
+          <p:nvPr/>
+        </p:nvSpPr>
+        <p:spPr>
+          <a:xfrm>
+            <a:off x="10241280" y="6565392"/>
+            <a:ext cx="1371600" cy="219456"/>
+          </a:xfrm>
+          <a:prstGeom prst="rect">
+            <a:avLst/>
+          </a:prstGeom>
+          <a:noFill/>
+        </p:spPr>
+        <p:txBody>
+          <a:bodyPr wrap="square" anchor="t"/>
+          <a:lstStyle/>
+          <a:p>
+            <a:pPr algn="r">
+              <a:spcBef>
+                <a:spcPts val="0"/>
+              </a:spcBef>
+              <a:spcAft>
+                <a:spcPts val="0"/>
+              </a:spcAft>
+            </a:pPr>
+            <a:r>
+              <a:rPr sz="1000" b="0">
+                <a:solidFill>
+                  <a:srgbClr val="6B6B6B"/>
+                </a:solidFill>
+                <a:latin typeface="PingFang SC"/>
+                <a:ea typeface="PingFang SC"/>
+              </a:rPr>
+              <a:t>11 / 12</a:t>
+            </a:r>
+          </a:p>
+        </p:txBody>
+      </p:sp>
+      <p:sp>
+        <p:nvSpPr>
+          <p:cNvPr id="22" name="Rectangle 21"/>
+          <p:cNvSpPr/>
+          <p:nvPr/>
+        </p:nvSpPr>
+        <p:spPr>
+          <a:xfrm>
+            <a:off x="566928" y="6510528"/>
+            <a:ext cx="11045952" cy="9525"/>
+          </a:xfrm>
+          <a:prstGeom prst="rect">
+            <a:avLst/>
+          </a:prstGeom>
+          <a:solidFill>
+            <a:srgbClr val="E6E6E6"/>
+          </a:solidFill>
+          <a:ln>
+            <a:noFill/>
+          </a:ln>
+          <a:effectLst/>
+        </p:spPr>
+        <p:style>
+          <a:lnRef idx="1">
+            <a:schemeClr val="accent1"/>
+          </a:lnRef>
+          <a:fillRef idx="3">
+            <a:schemeClr val="accent1"/>
+          </a:fillRef>
+          <a:effectRef idx="2">
+            <a:schemeClr val="accent1"/>
+          </a:effectRef>
+          <a:fontRef idx="minor">
+            <a:schemeClr val="lt1"/>
+          </a:fontRef>
+        </p:style>
+        <p:txBody>
+          <a:bodyPr rtlCol="0" anchor="ctr"/>
+          <a:lstStyle/>
+          <a:p>
+            <a:pPr algn="ctr"/>
+          </a:p>
+        </p:txBody>
+      </p:sp>
+    </p:spTree>
+  </p:cSld>
+  <p:clrMapOvr>
+    <a:masterClrMapping/>
+  </p:clrMapOvr>
+</p:sld>
+</file>
+
+<file path=ppt/slides/slide12.xml><?xml version="1.0" encoding="utf-8"?>
+<p:sld xmlns:a="http://schemas.openxmlformats.org/drawingml/2006/main" xmlns:p="http://schemas.openxmlformats.org/presentationml/2006/main" xmlns:r="http://schemas.openxmlformats.org/officeDocument/2006/relationships">
+  <p:cSld>
+    <p:spTree>
+      <p:nvGrpSpPr>
+        <p:cNvPr id="1" name=""/>
+        <p:cNvGrpSpPr/>
+        <p:nvPr/>
+      </p:nvGrpSpPr>
+      <p:grpSpPr/>
+      <p:sp>
+        <p:nvSpPr>
+          <p:cNvPr id="2" name="Rectangle 1"/>
+          <p:cNvSpPr/>
+          <p:nvPr/>
+        </p:nvSpPr>
+        <p:spPr>
+          <a:xfrm>
+            <a:off x="0" y="0"/>
+            <a:ext cx="12191695" cy="6858000"/>
+          </a:xfrm>
+          <a:prstGeom prst="rect">
+            <a:avLst/>
+          </a:prstGeom>
+          <a:solidFill>
+            <a:srgbClr val="FFFFFF"/>
+          </a:solidFill>
+          <a:ln>
+            <a:noFill/>
+          </a:ln>
+          <a:effectLst/>
+        </p:spPr>
+        <p:style>
+          <a:lnRef idx="1">
+            <a:schemeClr val="accent1"/>
+          </a:lnRef>
+          <a:fillRef idx="3">
+            <a:schemeClr val="accent1"/>
+          </a:fillRef>
+          <a:effectRef idx="2">
+            <a:schemeClr val="accent1"/>
+          </a:effectRef>
+          <a:fontRef idx="minor">
+            <a:schemeClr val="lt1"/>
+          </a:fontRef>
+        </p:style>
+        <p:txBody>
+          <a:bodyPr rtlCol="0" anchor="ctr"/>
+          <a:lstStyle/>
+          <a:p>
+            <a:pPr algn="ctr"/>
+          </a:p>
+        </p:txBody>
+      </p:sp>
+      <p:sp>
+        <p:nvSpPr>
+          <p:cNvPr id="3" name="TextBox 2"/>
+          <p:cNvSpPr txBox="1"/>
+          <p:nvPr/>
+        </p:nvSpPr>
+        <p:spPr>
+          <a:xfrm>
+            <a:off x="566928" y="219456"/>
+            <a:ext cx="10972800" cy="201168"/>
+          </a:xfrm>
+          <a:prstGeom prst="rect">
+            <a:avLst/>
+          </a:prstGeom>
+          <a:noFill/>
+        </p:spPr>
+        <p:txBody>
+          <a:bodyPr wrap="square" anchor="t"/>
+          <a:lstStyle/>
+          <a:p>
+            <a:pPr algn="l">
+              <a:spcBef>
+                <a:spcPts val="0"/>
+              </a:spcBef>
+              <a:spcAft>
+                <a:spcPts val="0"/>
+              </a:spcAft>
+            </a:pPr>
+            <a:r>
+              <a:rPr sz="1100" b="1">
+                <a:solidFill>
+                  <a:srgbClr val="FF004E"/>
+                </a:solidFill>
+                <a:latin typeface="PingFang SC"/>
+                <a:ea typeface="PingFang SC"/>
+              </a:rPr>
+              <a:t>11  /  九十天必须交出来的东西</a:t>
             </a:r>
           </a:p>
         </p:txBody>
@@ -5772,7 +6856,7 @@
                 <a:latin typeface="PingFang SC"/>
                 <a:ea typeface="PingFang SC"/>
               </a:rPr>
-              <a:t>EN+ZH 首页 / 三社媒首发</a:t>
+              <a:t>EN+ZH 首页 / LI+IG 首发</a:t>
             </a:r>
           </a:p>
         </p:txBody>
@@ -6033,7 +7117,7 @@
                 <a:latin typeface="PingFang SC"/>
                 <a:ea typeface="PingFang SC"/>
               </a:rPr>
-              <a:t>3 语 + 3 账号</a:t>
+              <a:t>2 个账号先活</a:t>
             </a:r>
           </a:p>
         </p:txBody>
@@ -6207,7 +7291,7 @@
                 <a:latin typeface="PingFang SC"/>
                 <a:ea typeface="PingFang SC"/>
               </a:rPr>
-              <a:t>三支视频可嵌官网</a:t>
+              <a:t>7 秒 SCORE 片 + 表单跳转</a:t>
             </a:r>
           </a:p>
         </p:txBody>
@@ -6294,7 +7378,7 @@
                 <a:latin typeface="PingFang SC"/>
                 <a:ea typeface="PingFang SC"/>
               </a:rPr>
-              <a:t>社媒 · 邮件</a:t>
+              <a:t>独立站 · 视频</a:t>
             </a:r>
           </a:p>
         </p:txBody>
@@ -6468,7 +7552,7 @@
                 <a:latin typeface="PingFang SC"/>
                 <a:ea typeface="PingFang SC"/>
               </a:rPr>
-              <a:t>60s+30s+30s</a:t>
+              <a:t>7s → 表单</a:t>
             </a:r>
           </a:p>
         </p:txBody>
@@ -9680,7 +10764,7 @@
                 <a:latin typeface="PingFang SC"/>
                 <a:ea typeface="PingFang SC"/>
               </a:rPr>
-              <a:t>11 / 11</a:t>
+              <a:t>12 / 12</a:t>
             </a:r>
           </a:p>
         </p:txBody>
@@ -10827,7 +11911,7 @@
                 <a:latin typeface="PingFang SC"/>
                 <a:ea typeface="PingFang SC"/>
               </a:rPr>
-              <a:t>2 / 11</a:t>
+              <a:t>2 / 12</a:t>
             </a:r>
           </a:p>
         </p:txBody>
@@ -13420,7 +14504,7 @@
                 <a:latin typeface="PingFang SC"/>
                 <a:ea typeface="PingFang SC"/>
               </a:rPr>
-              <a:t>3 / 11</a:t>
+              <a:t>3 / 12</a:t>
             </a:r>
           </a:p>
         </p:txBody>
@@ -14519,7 +15603,7 @@
                 <a:latin typeface="PingFang SC"/>
                 <a:ea typeface="PingFang SC"/>
               </a:rPr>
-              <a:t>4 / 11</a:t>
+              <a:t>4 / 12</a:t>
             </a:r>
           </a:p>
         </p:txBody>
@@ -15419,7 +16503,7 @@
                 <a:latin typeface="PingFang SC"/>
                 <a:ea typeface="PingFang SC"/>
               </a:rPr>
-              <a:t>三支片子、一份项目 PDF。所有邮件、社媒、展会二维码指回这里。</a:t>
+              <a:t>7 秒 SCORE 片播完跳转表单（主题 Scoreboard Handball）。再加系统片 / LED 片和项目 PDF。</a:t>
             </a:r>
           </a:p>
         </p:txBody>
@@ -15873,7 +16957,7 @@
                 <a:latin typeface="PingFang SC"/>
                 <a:ea typeface="PingFang SC"/>
               </a:rPr>
-              <a:t>5 / 11</a:t>
+              <a:t>5 / 12</a:t>
             </a:r>
           </a:p>
         </p:txBody>
@@ -16061,7 +17145,7 @@
                 <a:latin typeface="PingFang SC"/>
                 <a:ea typeface="PingFang SC"/>
               </a:rPr>
-              <a:t>只做三家。发现场，不发参数。展会周加码。</a:t>
+              <a:t>先开两家验证。瑞士独立号注册。发现场，不发参数。</a:t>
             </a:r>
           </a:p>
         </p:txBody>
@@ -16119,7 +17203,7 @@
         <p:spPr>
           <a:xfrm>
             <a:off x="566928" y="1024128"/>
-            <a:ext cx="1554480" cy="960120"/>
+            <a:ext cx="1691640" cy="749808"/>
           </a:xfrm>
           <a:prstGeom prst="rect">
             <a:avLst/>
@@ -16165,7 +17249,7 @@
         <p:spPr>
           <a:xfrm>
             <a:off x="640080" y="1060704"/>
-            <a:ext cx="1408176" cy="905256"/>
+            <a:ext cx="1545336" cy="694944"/>
           </a:xfrm>
           <a:prstGeom prst="rect">
             <a:avLst/>
@@ -16205,8 +17289,8 @@
         </p:nvSpPr>
         <p:spPr>
           <a:xfrm>
-            <a:off x="2121408" y="1024128"/>
-            <a:ext cx="2240280" cy="960120"/>
+            <a:off x="2258568" y="1024128"/>
+            <a:ext cx="2148840" cy="749808"/>
           </a:xfrm>
           <a:prstGeom prst="rect">
             <a:avLst/>
@@ -16251,8 +17335,8 @@
         </p:nvSpPr>
         <p:spPr>
           <a:xfrm>
-            <a:off x="2194560" y="1060704"/>
-            <a:ext cx="2093976" cy="905256"/>
+            <a:off x="2331720" y="1060704"/>
+            <a:ext cx="2002536" cy="694944"/>
           </a:xfrm>
           <a:prstGeom prst="rect">
             <a:avLst/>
@@ -16279,7 +17363,7 @@
                 <a:latin typeface="PingFang SC"/>
                 <a:ea typeface="PingFang SC"/>
               </a:rPr>
-              <a:t>为什么</a:t>
+              <a:t>阶段</a:t>
             </a:r>
           </a:p>
         </p:txBody>
@@ -16292,8 +17376,8 @@
         </p:nvSpPr>
         <p:spPr>
           <a:xfrm>
-            <a:off x="4361688" y="1024128"/>
-            <a:ext cx="3154680" cy="960120"/>
+            <a:off x="4407408" y="1024128"/>
+            <a:ext cx="3063240" cy="749808"/>
           </a:xfrm>
           <a:prstGeom prst="rect">
             <a:avLst/>
@@ -16338,8 +17422,8 @@
         </p:nvSpPr>
         <p:spPr>
           <a:xfrm>
-            <a:off x="4434840" y="1060704"/>
-            <a:ext cx="3008376" cy="905256"/>
+            <a:off x="4480560" y="1060704"/>
+            <a:ext cx="2916936" cy="694944"/>
           </a:xfrm>
           <a:prstGeom prst="rect">
             <a:avLst/>
@@ -16379,8 +17463,8 @@
         </p:nvSpPr>
         <p:spPr>
           <a:xfrm>
-            <a:off x="7516368" y="1024128"/>
-            <a:ext cx="1828800" cy="960120"/>
+            <a:off x="7470648" y="1024128"/>
+            <a:ext cx="1965960" cy="749808"/>
           </a:xfrm>
           <a:prstGeom prst="rect">
             <a:avLst/>
@@ -16425,8 +17509,8 @@
         </p:nvSpPr>
         <p:spPr>
           <a:xfrm>
-            <a:off x="7589520" y="1060704"/>
-            <a:ext cx="1682496" cy="905256"/>
+            <a:off x="7543800" y="1060704"/>
+            <a:ext cx="1819656" cy="694944"/>
           </a:xfrm>
           <a:prstGeom prst="rect">
             <a:avLst/>
@@ -16466,8 +17550,8 @@
         </p:nvSpPr>
         <p:spPr>
           <a:xfrm>
-            <a:off x="9345168" y="1024128"/>
-            <a:ext cx="2240280" cy="960120"/>
+            <a:off x="9436608" y="1024128"/>
+            <a:ext cx="2148840" cy="749808"/>
           </a:xfrm>
           <a:prstGeom prst="rect">
             <a:avLst/>
@@ -16512,8 +17596,8 @@
         </p:nvSpPr>
         <p:spPr>
           <a:xfrm>
-            <a:off x="9418320" y="1060704"/>
-            <a:ext cx="2093976" cy="905256"/>
+            <a:off x="9509760" y="1060704"/>
+            <a:ext cx="2002536" cy="694944"/>
           </a:xfrm>
           <a:prstGeom prst="rect">
             <a:avLst/>
@@ -16540,7 +17624,7 @@
                 <a:latin typeface="PingFang SC"/>
                 <a:ea typeface="PingFang SC"/>
               </a:rPr>
-              <a:t>谁来发</a:t>
+              <a:t>谁</a:t>
             </a:r>
           </a:p>
         </p:txBody>
@@ -16553,8 +17637,8 @@
         </p:nvSpPr>
         <p:spPr>
           <a:xfrm>
-            <a:off x="566928" y="1984248"/>
-            <a:ext cx="1554480" cy="960120"/>
+            <a:off x="566928" y="1773936"/>
+            <a:ext cx="1691640" cy="749808"/>
           </a:xfrm>
           <a:prstGeom prst="rect">
             <a:avLst/>
@@ -16599,8 +17683,8 @@
         </p:nvSpPr>
         <p:spPr>
           <a:xfrm>
-            <a:off x="640080" y="2020824"/>
-            <a:ext cx="1408176" cy="905256"/>
+            <a:off x="640080" y="1810512"/>
+            <a:ext cx="1545336" cy="694944"/>
           </a:xfrm>
           <a:prstGeom prst="rect">
             <a:avLst/>
@@ -16620,7 +17704,7 @@
               </a:spcAft>
             </a:pPr>
             <a:r>
-              <a:rPr sz="1200" b="1">
+              <a:rPr sz="1100" b="1">
                 <a:solidFill>
                   <a:srgbClr val="111111"/>
                 </a:solidFill>
@@ -16640,8 +17724,8 @@
         </p:nvSpPr>
         <p:spPr>
           <a:xfrm>
-            <a:off x="2121408" y="1984248"/>
-            <a:ext cx="2240280" cy="960120"/>
+            <a:off x="2258568" y="1773936"/>
+            <a:ext cx="2148840" cy="749808"/>
           </a:xfrm>
           <a:prstGeom prst="rect">
             <a:avLst/>
@@ -16686,8 +17770,8 @@
         </p:nvSpPr>
         <p:spPr>
           <a:xfrm>
-            <a:off x="2194560" y="2020824"/>
-            <a:ext cx="2093976" cy="905256"/>
+            <a:off x="2331720" y="1810512"/>
+            <a:ext cx="2002536" cy="694944"/>
           </a:xfrm>
           <a:prstGeom prst="rect">
             <a:avLst/>
@@ -16707,34 +17791,34 @@
               </a:spcAft>
             </a:pPr>
             <a:r>
-              <a:rPr sz="1200" b="0">
+              <a:rPr sz="1100" b="0">
                 <a:solidFill>
                   <a:srgbClr val="111111"/>
                 </a:solidFill>
                 <a:latin typeface="PingFang SC"/>
                 <a:ea typeface="PingFang SC"/>
               </a:rPr>
-              <a:t>买家在这里。</a:t>
-            </a:r>
-          </a:p>
-          <a:p>
-            <a:pPr algn="l">
-              <a:spcBef>
-                <a:spcPts val="0"/>
-              </a:spcBef>
-              <a:spcAft>
-                <a:spcPts val="0"/>
-              </a:spcAft>
-            </a:pPr>
-            <a:r>
-              <a:rPr sz="1200" b="0">
+              <a:t>现在开</a:t>
+            </a:r>
+          </a:p>
+          <a:p>
+            <a:pPr algn="l">
+              <a:spcBef>
+                <a:spcPts val="0"/>
+              </a:spcBef>
+              <a:spcAft>
+                <a:spcPts val="0"/>
+              </a:spcAft>
+            </a:pPr>
+            <a:r>
+              <a:rPr sz="1100" b="0">
                 <a:solidFill>
                   <a:srgbClr val="111111"/>
                 </a:solidFill>
                 <a:latin typeface="PingFang SC"/>
                 <a:ea typeface="PingFang SC"/>
               </a:rPr>
-              <a:t>获客主场。</a:t>
+              <a:t>商务获客主场</a:t>
             </a:r>
           </a:p>
         </p:txBody>
@@ -16747,8 +17831,8 @@
         </p:nvSpPr>
         <p:spPr>
           <a:xfrm>
-            <a:off x="4361688" y="1984248"/>
-            <a:ext cx="3154680" cy="960120"/>
+            <a:off x="4407408" y="1773936"/>
+            <a:ext cx="3063240" cy="749808"/>
           </a:xfrm>
           <a:prstGeom prst="rect">
             <a:avLst/>
@@ -16793,8 +17877,8 @@
         </p:nvSpPr>
         <p:spPr>
           <a:xfrm>
-            <a:off x="4434840" y="2020824"/>
-            <a:ext cx="3008376" cy="905256"/>
+            <a:off x="4480560" y="1810512"/>
+            <a:ext cx="2916936" cy="694944"/>
           </a:xfrm>
           <a:prstGeom prst="rect">
             <a:avLst/>
@@ -16814,7 +17898,7 @@
               </a:spcAft>
             </a:pPr>
             <a:r>
-              <a:rPr sz="1200" b="0">
+              <a:rPr sz="1100" b="0">
                 <a:solidFill>
                   <a:srgbClr val="111111"/>
                 </a:solidFill>
@@ -16834,14 +17918,14 @@
               </a:spcAft>
             </a:pPr>
             <a:r>
-              <a:rPr sz="1200" b="0">
+              <a:rPr sz="1100" b="0">
                 <a:solidFill>
                   <a:srgbClr val="111111"/>
                 </a:solidFill>
                 <a:latin typeface="PingFang SC"/>
                 <a:ea typeface="PingFang SC"/>
               </a:rPr>
-              <a:t>展会约见入口。</a:t>
+              <a:t>展会约见。德语母版。</a:t>
             </a:r>
           </a:p>
         </p:txBody>
@@ -16854,8 +17938,8 @@
         </p:nvSpPr>
         <p:spPr>
           <a:xfrm>
-            <a:off x="7516368" y="1984248"/>
-            <a:ext cx="1828800" cy="960120"/>
+            <a:off x="7470648" y="1773936"/>
+            <a:ext cx="1965960" cy="749808"/>
           </a:xfrm>
           <a:prstGeom prst="rect">
             <a:avLst/>
@@ -16900,8 +17984,8 @@
         </p:nvSpPr>
         <p:spPr>
           <a:xfrm>
-            <a:off x="7589520" y="2020824"/>
-            <a:ext cx="1682496" cy="905256"/>
+            <a:off x="7543800" y="1810512"/>
+            <a:ext cx="1819656" cy="694944"/>
           </a:xfrm>
           <a:prstGeom prst="rect">
             <a:avLst/>
@@ -16921,34 +18005,34 @@
               </a:spcAft>
             </a:pPr>
             <a:r>
-              <a:rPr sz="1200" b="0">
+              <a:rPr sz="1100" b="0">
                 <a:solidFill>
                   <a:srgbClr val="111111"/>
                 </a:solidFill>
                 <a:latin typeface="PingFang SC"/>
                 <a:ea typeface="PingFang SC"/>
               </a:rPr>
-              <a:t>2 条/周</a:t>
-            </a:r>
-          </a:p>
-          <a:p>
-            <a:pPr algn="l">
-              <a:spcBef>
-                <a:spcPts val="0"/>
-              </a:spcBef>
-              <a:spcAft>
-                <a:spcPts val="0"/>
-              </a:spcAft>
-            </a:pPr>
-            <a:r>
-              <a:rPr sz="1200" b="0">
+              <a:t>2–3 天一条</a:t>
+            </a:r>
+          </a:p>
+          <a:p>
+            <a:pPr algn="l">
+              <a:spcBef>
+                <a:spcPts val="0"/>
+              </a:spcBef>
+              <a:spcAft>
+                <a:spcPts val="0"/>
+              </a:spcAft>
+            </a:pPr>
+            <a:r>
+              <a:rPr sz="1100" b="0">
                 <a:solidFill>
                   <a:srgbClr val="111111"/>
                 </a:solidFill>
                 <a:latin typeface="PingFang SC"/>
                 <a:ea typeface="PingFang SC"/>
               </a:rPr>
-              <a:t>展会周 4 条</a:t>
+              <a:t>展会周加倍</a:t>
             </a:r>
           </a:p>
         </p:txBody>
@@ -16961,8 +18045,8 @@
         </p:nvSpPr>
         <p:spPr>
           <a:xfrm>
-            <a:off x="9345168" y="1984248"/>
-            <a:ext cx="2240280" cy="960120"/>
+            <a:off x="9436608" y="1773936"/>
+            <a:ext cx="2148840" cy="749808"/>
           </a:xfrm>
           <a:prstGeom prst="rect">
             <a:avLst/>
@@ -17007,8 +18091,8 @@
         </p:nvSpPr>
         <p:spPr>
           <a:xfrm>
-            <a:off x="9418320" y="2020824"/>
-            <a:ext cx="2093976" cy="905256"/>
+            <a:off x="9509760" y="1810512"/>
+            <a:ext cx="2002536" cy="694944"/>
           </a:xfrm>
           <a:prstGeom prst="rect">
             <a:avLst/>
@@ -17028,7 +18112,7 @@
               </a:spcAft>
             </a:pPr>
             <a:r>
-              <a:rPr sz="1200" b="0">
+              <a:rPr sz="1100" b="0">
                 <a:solidFill>
                   <a:srgbClr val="111111"/>
                 </a:solidFill>
@@ -17048,7 +18132,7 @@
               </a:spcAft>
             </a:pPr>
             <a:r>
-              <a:rPr sz="1200" b="0">
+              <a:rPr sz="1100" b="0">
                 <a:solidFill>
                   <a:srgbClr val="111111"/>
                 </a:solidFill>
@@ -17068,8 +18152,8 @@
         </p:nvSpPr>
         <p:spPr>
           <a:xfrm>
-            <a:off x="566928" y="2944368"/>
-            <a:ext cx="1554480" cy="960120"/>
+            <a:off x="566928" y="2523744"/>
+            <a:ext cx="1691640" cy="749808"/>
           </a:xfrm>
           <a:prstGeom prst="rect">
             <a:avLst/>
@@ -17114,8 +18198,8 @@
         </p:nvSpPr>
         <p:spPr>
           <a:xfrm>
-            <a:off x="640080" y="2980944"/>
-            <a:ext cx="1408176" cy="905256"/>
+            <a:off x="640080" y="2560320"/>
+            <a:ext cx="1545336" cy="694944"/>
           </a:xfrm>
           <a:prstGeom prst="rect">
             <a:avLst/>
@@ -17135,7 +18219,7 @@
               </a:spcAft>
             </a:pPr>
             <a:r>
-              <a:rPr sz="1200" b="1">
+              <a:rPr sz="1100" b="1">
                 <a:solidFill>
                   <a:srgbClr val="111111"/>
                 </a:solidFill>
@@ -17155,8 +18239,8 @@
         </p:nvSpPr>
         <p:spPr>
           <a:xfrm>
-            <a:off x="2121408" y="2944368"/>
-            <a:ext cx="2240280" cy="960120"/>
+            <a:off x="2258568" y="2523744"/>
+            <a:ext cx="2148840" cy="749808"/>
           </a:xfrm>
           <a:prstGeom prst="rect">
             <a:avLst/>
@@ -17201,8 +18285,8 @@
         </p:nvSpPr>
         <p:spPr>
           <a:xfrm>
-            <a:off x="2194560" y="2980944"/>
-            <a:ext cx="2093976" cy="905256"/>
+            <a:off x="2331720" y="2560320"/>
+            <a:ext cx="2002536" cy="694944"/>
           </a:xfrm>
           <a:prstGeom prst="rect">
             <a:avLst/>
@@ -17222,34 +18306,34 @@
               </a:spcAft>
             </a:pPr>
             <a:r>
-              <a:rPr sz="1200" b="0">
+              <a:rPr sz="1100" b="0">
                 <a:solidFill>
                   <a:srgbClr val="111111"/>
                 </a:solidFill>
                 <a:latin typeface="PingFang SC"/>
                 <a:ea typeface="PingFang SC"/>
               </a:rPr>
-              <a:t>画面即证据。</a:t>
-            </a:r>
-          </a:p>
-          <a:p>
-            <a:pPr algn="l">
-              <a:spcBef>
-                <a:spcPts val="0"/>
-              </a:spcBef>
-              <a:spcAft>
-                <a:spcPts val="0"/>
-              </a:spcAft>
-            </a:pPr>
-            <a:r>
-              <a:rPr sz="1200" b="0">
+              <a:t>现在开</a:t>
+            </a:r>
+          </a:p>
+          <a:p>
+            <a:pPr algn="l">
+              <a:spcBef>
+                <a:spcPts val="0"/>
+              </a:spcBef>
+              <a:spcAft>
+                <a:spcPts val="0"/>
+              </a:spcAft>
+            </a:pPr>
+            <a:r>
+              <a:rPr sz="1100" b="0">
                 <a:solidFill>
                   <a:srgbClr val="111111"/>
                 </a:solidFill>
                 <a:latin typeface="PingFang SC"/>
                 <a:ea typeface="PingFang SC"/>
               </a:rPr>
-              <a:t>给集成商转发。</a:t>
+              <a:t>画面即证据</a:t>
             </a:r>
           </a:p>
         </p:txBody>
@@ -17262,8 +18346,8 @@
         </p:nvSpPr>
         <p:spPr>
           <a:xfrm>
-            <a:off x="4361688" y="2944368"/>
-            <a:ext cx="3154680" cy="960120"/>
+            <a:off x="4407408" y="2523744"/>
+            <a:ext cx="3063240" cy="749808"/>
           </a:xfrm>
           <a:prstGeom prst="rect">
             <a:avLst/>
@@ -17308,8 +18392,8 @@
         </p:nvSpPr>
         <p:spPr>
           <a:xfrm>
-            <a:off x="4434840" y="2980944"/>
-            <a:ext cx="3008376" cy="905256"/>
+            <a:off x="4480560" y="2560320"/>
+            <a:ext cx="2916936" cy="694944"/>
           </a:xfrm>
           <a:prstGeom prst="rect">
             <a:avLst/>
@@ -17329,27 +18413,27 @@
               </a:spcAft>
             </a:pPr>
             <a:r>
-              <a:rPr sz="1200" b="0">
+              <a:rPr sz="1100" b="0">
                 <a:solidFill>
                   <a:srgbClr val="111111"/>
                 </a:solidFill>
                 <a:latin typeface="PingFang SC"/>
                 <a:ea typeface="PingFang SC"/>
               </a:rPr>
-              <a:t>控制室 15 秒、LED 近景、</a:t>
-            </a:r>
-          </a:p>
-          <a:p>
-            <a:pPr algn="l">
-              <a:spcBef>
-                <a:spcPts val="0"/>
-              </a:spcBef>
-              <a:spcAft>
-                <a:spcPts val="0"/>
-              </a:spcAft>
-            </a:pPr>
-            <a:r>
-              <a:rPr sz="1200" b="0">
+              <a:t>Reels：控制室、LED 近景、</a:t>
+            </a:r>
+          </a:p>
+          <a:p>
+            <a:pPr algn="l">
+              <a:spcBef>
+                <a:spcPts val="0"/>
+              </a:spcBef>
+              <a:spcAft>
+                <a:spcPts val="0"/>
+              </a:spcAft>
+            </a:pPr>
+            <a:r>
+              <a:rPr sz="1100" b="0">
                 <a:solidFill>
                   <a:srgbClr val="111111"/>
                 </a:solidFill>
@@ -17369,8 +18453,8 @@
         </p:nvSpPr>
         <p:spPr>
           <a:xfrm>
-            <a:off x="7516368" y="2944368"/>
-            <a:ext cx="1828800" cy="960120"/>
+            <a:off x="7470648" y="2523744"/>
+            <a:ext cx="1965960" cy="749808"/>
           </a:xfrm>
           <a:prstGeom prst="rect">
             <a:avLst/>
@@ -17415,8 +18499,8 @@
         </p:nvSpPr>
         <p:spPr>
           <a:xfrm>
-            <a:off x="7589520" y="2980944"/>
-            <a:ext cx="1682496" cy="905256"/>
+            <a:off x="7543800" y="2560320"/>
+            <a:ext cx="1819656" cy="694944"/>
           </a:xfrm>
           <a:prstGeom prst="rect">
             <a:avLst/>
@@ -17436,14 +18520,14 @@
               </a:spcAft>
             </a:pPr>
             <a:r>
-              <a:rPr sz="1200" b="0">
+              <a:rPr sz="1100" b="0">
                 <a:solidFill>
                   <a:srgbClr val="111111"/>
                 </a:solidFill>
                 <a:latin typeface="PingFang SC"/>
                 <a:ea typeface="PingFang SC"/>
               </a:rPr>
-              <a:t>3 条/周</a:t>
+              <a:t>2–3 天一条</a:t>
             </a:r>
           </a:p>
         </p:txBody>
@@ -17456,8 +18540,8 @@
         </p:nvSpPr>
         <p:spPr>
           <a:xfrm>
-            <a:off x="9345168" y="2944368"/>
-            <a:ext cx="2240280" cy="960120"/>
+            <a:off x="9436608" y="2523744"/>
+            <a:ext cx="2148840" cy="749808"/>
           </a:xfrm>
           <a:prstGeom prst="rect">
             <a:avLst/>
@@ -17502,8 +18586,8 @@
         </p:nvSpPr>
         <p:spPr>
           <a:xfrm>
-            <a:off x="9418320" y="2980944"/>
-            <a:ext cx="2093976" cy="905256"/>
+            <a:off x="9509760" y="2560320"/>
+            <a:ext cx="2002536" cy="694944"/>
           </a:xfrm>
           <a:prstGeom prst="rect">
             <a:avLst/>
@@ -17523,7 +18607,7 @@
               </a:spcAft>
             </a:pPr>
             <a:r>
-              <a:rPr sz="1200" b="0">
+              <a:rPr sz="1100" b="0">
                 <a:solidFill>
                   <a:srgbClr val="111111"/>
                 </a:solidFill>
@@ -17543,14 +18627,14 @@
               </a:spcAft>
             </a:pPr>
             <a:r>
-              <a:rPr sz="1200" b="0">
+              <a:rPr sz="1100" b="0">
                 <a:solidFill>
                   <a:srgbClr val="111111"/>
                 </a:solidFill>
                 <a:latin typeface="PingFang SC"/>
                 <a:ea typeface="PingFang SC"/>
               </a:rPr>
-              <a:t>素材来自现场</a:t>
+              <a:t>现场素材</a:t>
             </a:r>
           </a:p>
         </p:txBody>
@@ -17563,8 +18647,8 @@
         </p:nvSpPr>
         <p:spPr>
           <a:xfrm>
-            <a:off x="566928" y="3904488"/>
-            <a:ext cx="1554480" cy="960120"/>
+            <a:off x="566928" y="3273552"/>
+            <a:ext cx="1691640" cy="749808"/>
           </a:xfrm>
           <a:prstGeom prst="rect">
             <a:avLst/>
@@ -17609,8 +18693,8 @@
         </p:nvSpPr>
         <p:spPr>
           <a:xfrm>
-            <a:off x="640080" y="3941064"/>
-            <a:ext cx="1408176" cy="905256"/>
+            <a:off x="640080" y="3310128"/>
+            <a:ext cx="1545336" cy="694944"/>
           </a:xfrm>
           <a:prstGeom prst="rect">
             <a:avLst/>
@@ -17630,14 +18714,14 @@
               </a:spcAft>
             </a:pPr>
             <a:r>
-              <a:rPr sz="1200" b="1">
+              <a:rPr sz="1100" b="1">
                 <a:solidFill>
                   <a:srgbClr val="111111"/>
                 </a:solidFill>
                 <a:latin typeface="PingFang SC"/>
                 <a:ea typeface="PingFang SC"/>
               </a:rPr>
-              <a:t>YouTube</a:t>
+              <a:t>X / Twitter</a:t>
             </a:r>
           </a:p>
         </p:txBody>
@@ -17650,8 +18734,8 @@
         </p:nvSpPr>
         <p:spPr>
           <a:xfrm>
-            <a:off x="2121408" y="3904488"/>
-            <a:ext cx="2240280" cy="960120"/>
+            <a:off x="2258568" y="3273552"/>
+            <a:ext cx="2148840" cy="749808"/>
           </a:xfrm>
           <a:prstGeom prst="rect">
             <a:avLst/>
@@ -17696,8 +18780,8 @@
         </p:nvSpPr>
         <p:spPr>
           <a:xfrm>
-            <a:off x="2194560" y="3941064"/>
-            <a:ext cx="2093976" cy="905256"/>
+            <a:off x="2331720" y="3310128"/>
+            <a:ext cx="2002536" cy="694944"/>
           </a:xfrm>
           <a:prstGeom prst="rect">
             <a:avLst/>
@@ -17717,34 +18801,34 @@
               </a:spcAft>
             </a:pPr>
             <a:r>
-              <a:rPr sz="1200" b="0">
+              <a:rPr sz="1100" b="0">
                 <a:solidFill>
                   <a:srgbClr val="111111"/>
                 </a:solidFill>
                 <a:latin typeface="PingFang SC"/>
                 <a:ea typeface="PingFang SC"/>
               </a:rPr>
-              <a:t>能被搜到。</a:t>
-            </a:r>
-          </a:p>
-          <a:p>
-            <a:pPr algn="l">
-              <a:spcBef>
-                <a:spcPts val="0"/>
-              </a:spcBef>
-              <a:spcAft>
-                <a:spcPts val="0"/>
-              </a:spcAft>
-            </a:pPr>
-            <a:r>
-              <a:rPr sz="1200" b="0">
+              <a:t>两家跑通再开</a:t>
+            </a:r>
+          </a:p>
+          <a:p>
+            <a:pPr algn="l">
+              <a:spcBef>
+                <a:spcPts val="0"/>
+              </a:spcBef>
+              <a:spcAft>
+                <a:spcPts val="0"/>
+              </a:spcAft>
+            </a:pPr>
+            <a:r>
+              <a:rPr sz="1100" b="0">
                 <a:solidFill>
                   <a:srgbClr val="111111"/>
                 </a:solidFill>
                 <a:latin typeface="PingFang SC"/>
                 <a:ea typeface="PingFang SC"/>
               </a:rPr>
-              <a:t>官网和邮件都嵌。</a:t>
+              <a:t>图文与行业动态</a:t>
             </a:r>
           </a:p>
         </p:txBody>
@@ -17757,8 +18841,8 @@
         </p:nvSpPr>
         <p:spPr>
           <a:xfrm>
-            <a:off x="4361688" y="3904488"/>
-            <a:ext cx="3154680" cy="960120"/>
+            <a:off x="4407408" y="3273552"/>
+            <a:ext cx="3063240" cy="749808"/>
           </a:xfrm>
           <a:prstGeom prst="rect">
             <a:avLst/>
@@ -17803,8 +18887,8 @@
         </p:nvSpPr>
         <p:spPr>
           <a:xfrm>
-            <a:off x="4434840" y="3941064"/>
-            <a:ext cx="3008376" cy="905256"/>
+            <a:off x="4480560" y="3310128"/>
+            <a:ext cx="2916936" cy="694944"/>
           </a:xfrm>
           <a:prstGeom prst="rect">
             <a:avLst/>
@@ -17824,34 +18908,34 @@
               </a:spcAft>
             </a:pPr>
             <a:r>
-              <a:rPr sz="1200" b="0">
+              <a:rPr sz="1100" b="0">
                 <a:solidFill>
                   <a:srgbClr val="111111"/>
                 </a:solidFill>
                 <a:latin typeface="PingFang SC"/>
                 <a:ea typeface="PingFang SC"/>
               </a:rPr>
-              <a:t>60 秒系统片 + SCORE / LED</a:t>
-            </a:r>
-          </a:p>
-          <a:p>
-            <a:pPr algn="l">
-              <a:spcBef>
-                <a:spcPts val="0"/>
-              </a:spcBef>
-              <a:spcAft>
-                <a:spcPts val="0"/>
-              </a:spcAft>
-            </a:pPr>
-            <a:r>
-              <a:rPr sz="1200" b="0">
+              <a:t>一句现场、一张图、一个链。</a:t>
+            </a:r>
+          </a:p>
+          <a:p>
+            <a:pPr algn="l">
+              <a:spcBef>
+                <a:spcPts val="0"/>
+              </a:spcBef>
+              <a:spcAft>
+                <a:spcPts val="0"/>
+              </a:spcAft>
+            </a:pPr>
+            <a:r>
+              <a:rPr sz="1100" b="0">
                 <a:solidFill>
                   <a:srgbClr val="111111"/>
                 </a:solidFill>
                 <a:latin typeface="PingFang SC"/>
                 <a:ea typeface="PingFang SC"/>
               </a:rPr>
-              <a:t>各一支 30 秒。</a:t>
+              <a:t>对标 Stramatel：装机与比赛夜。</a:t>
             </a:r>
           </a:p>
         </p:txBody>
@@ -17864,8 +18948,8 @@
         </p:nvSpPr>
         <p:spPr>
           <a:xfrm>
-            <a:off x="7516368" y="3904488"/>
-            <a:ext cx="1828800" cy="960120"/>
+            <a:off x="7470648" y="3273552"/>
+            <a:ext cx="1965960" cy="749808"/>
           </a:xfrm>
           <a:prstGeom prst="rect">
             <a:avLst/>
@@ -17910,8 +18994,8 @@
         </p:nvSpPr>
         <p:spPr>
           <a:xfrm>
-            <a:off x="7589520" y="3941064"/>
-            <a:ext cx="1682496" cy="905256"/>
+            <a:off x="7543800" y="3310128"/>
+            <a:ext cx="1819656" cy="694944"/>
           </a:xfrm>
           <a:prstGeom prst="rect">
             <a:avLst/>
@@ -17931,14 +19015,14 @@
               </a:spcAft>
             </a:pPr>
             <a:r>
-              <a:rPr sz="1200" b="0">
+              <a:rPr sz="1100" b="0">
                 <a:solidFill>
                   <a:srgbClr val="111111"/>
                 </a:solidFill>
                 <a:latin typeface="PingFang SC"/>
                 <a:ea typeface="PingFang SC"/>
               </a:rPr>
-              <a:t>2 条/月</a:t>
+              <a:t>有事才发</a:t>
             </a:r>
           </a:p>
         </p:txBody>
@@ -17951,8 +19035,8 @@
         </p:nvSpPr>
         <p:spPr>
           <a:xfrm>
-            <a:off x="9345168" y="3904488"/>
-            <a:ext cx="2240280" cy="960120"/>
+            <a:off x="9436608" y="3273552"/>
+            <a:ext cx="2148840" cy="749808"/>
           </a:xfrm>
           <a:prstGeom prst="rect">
             <a:avLst/>
@@ -17997,8 +19081,8 @@
         </p:nvSpPr>
         <p:spPr>
           <a:xfrm>
-            <a:off x="9418320" y="3941064"/>
-            <a:ext cx="2093976" cy="905256"/>
+            <a:off x="9509760" y="3310128"/>
+            <a:ext cx="2002536" cy="694944"/>
           </a:xfrm>
           <a:prstGeom prst="rect">
             <a:avLst/>
@@ -18018,34 +19102,14 @@
               </a:spcAft>
             </a:pPr>
             <a:r>
-              <a:rPr sz="1200" b="0">
+              <a:rPr sz="1100" b="0">
                 <a:solidFill>
                   <a:srgbClr val="111111"/>
                 </a:solidFill>
                 <a:latin typeface="PingFang SC"/>
                 <a:ea typeface="PingFang SC"/>
               </a:rPr>
-              <a:t>Jürg 定调</a:t>
-            </a:r>
-          </a:p>
-          <a:p>
-            <a:pPr algn="l">
-              <a:spcBef>
-                <a:spcPts val="0"/>
-              </a:spcBef>
-              <a:spcAft>
-                <a:spcPts val="0"/>
-              </a:spcAft>
-            </a:pPr>
-            <a:r>
-              <a:rPr sz="1200" b="0">
-                <a:solidFill>
-                  <a:srgbClr val="111111"/>
-                </a:solidFill>
-                <a:latin typeface="PingFang SC"/>
-                <a:ea typeface="PingFang SC"/>
-              </a:rPr>
-              <a:t>Donglin 协助</a:t>
+              <a:t>Peter</a:t>
             </a:r>
           </a:p>
         </p:txBody>
@@ -18058,7 +19122,502 @@
         </p:nvSpPr>
         <p:spPr>
           <a:xfrm>
-            <a:off x="566928" y="5010912"/>
+            <a:off x="566928" y="4023360"/>
+            <a:ext cx="1691640" cy="749808"/>
+          </a:xfrm>
+          <a:prstGeom prst="rect">
+            <a:avLst/>
+          </a:prstGeom>
+          <a:solidFill>
+            <a:srgbClr val="FFFFFF"/>
+          </a:solidFill>
+          <a:ln w="9525">
+            <a:solidFill>
+              <a:srgbClr val="E6E6E6"/>
+            </a:solidFill>
+          </a:ln>
+          <a:effectLst/>
+        </p:spPr>
+        <p:style>
+          <a:lnRef idx="1">
+            <a:schemeClr val="accent1"/>
+          </a:lnRef>
+          <a:fillRef idx="3">
+            <a:schemeClr val="accent1"/>
+          </a:fillRef>
+          <a:effectRef idx="2">
+            <a:schemeClr val="accent1"/>
+          </a:effectRef>
+          <a:fontRef idx="minor">
+            <a:schemeClr val="lt1"/>
+          </a:fontRef>
+        </p:style>
+        <p:txBody>
+          <a:bodyPr rtlCol="0" anchor="ctr"/>
+          <a:lstStyle/>
+          <a:p>
+            <a:pPr algn="ctr"/>
+          </a:p>
+        </p:txBody>
+      </p:sp>
+      <p:sp>
+        <p:nvSpPr>
+          <p:cNvPr id="47" name="TextBox 46"/>
+          <p:cNvSpPr txBox="1"/>
+          <p:nvPr/>
+        </p:nvSpPr>
+        <p:spPr>
+          <a:xfrm>
+            <a:off x="640080" y="4059936"/>
+            <a:ext cx="1545336" cy="694944"/>
+          </a:xfrm>
+          <a:prstGeom prst="rect">
+            <a:avLst/>
+          </a:prstGeom>
+          <a:noFill/>
+        </p:spPr>
+        <p:txBody>
+          <a:bodyPr wrap="square" anchor="ctr"/>
+          <a:lstStyle/>
+          <a:p>
+            <a:pPr algn="l">
+              <a:spcBef>
+                <a:spcPts val="0"/>
+              </a:spcBef>
+              <a:spcAft>
+                <a:spcPts val="0"/>
+              </a:spcAft>
+            </a:pPr>
+            <a:r>
+              <a:rPr sz="1100" b="1">
+                <a:solidFill>
+                  <a:srgbClr val="111111"/>
+                </a:solidFill>
+                <a:latin typeface="PingFang SC"/>
+                <a:ea typeface="PingFang SC"/>
+              </a:rPr>
+              <a:t>YouTube</a:t>
+            </a:r>
+          </a:p>
+        </p:txBody>
+      </p:sp>
+      <p:sp>
+        <p:nvSpPr>
+          <p:cNvPr id="48" name="Rectangle 47"/>
+          <p:cNvSpPr/>
+          <p:nvPr/>
+        </p:nvSpPr>
+        <p:spPr>
+          <a:xfrm>
+            <a:off x="2258568" y="4023360"/>
+            <a:ext cx="2148840" cy="749808"/>
+          </a:xfrm>
+          <a:prstGeom prst="rect">
+            <a:avLst/>
+          </a:prstGeom>
+          <a:solidFill>
+            <a:srgbClr val="FFFFFF"/>
+          </a:solidFill>
+          <a:ln w="9525">
+            <a:solidFill>
+              <a:srgbClr val="E6E6E6"/>
+            </a:solidFill>
+          </a:ln>
+          <a:effectLst/>
+        </p:spPr>
+        <p:style>
+          <a:lnRef idx="1">
+            <a:schemeClr val="accent1"/>
+          </a:lnRef>
+          <a:fillRef idx="3">
+            <a:schemeClr val="accent1"/>
+          </a:fillRef>
+          <a:effectRef idx="2">
+            <a:schemeClr val="accent1"/>
+          </a:effectRef>
+          <a:fontRef idx="minor">
+            <a:schemeClr val="lt1"/>
+          </a:fontRef>
+        </p:style>
+        <p:txBody>
+          <a:bodyPr rtlCol="0" anchor="ctr"/>
+          <a:lstStyle/>
+          <a:p>
+            <a:pPr algn="ctr"/>
+          </a:p>
+        </p:txBody>
+      </p:sp>
+      <p:sp>
+        <p:nvSpPr>
+          <p:cNvPr id="49" name="TextBox 48"/>
+          <p:cNvSpPr txBox="1"/>
+          <p:nvPr/>
+        </p:nvSpPr>
+        <p:spPr>
+          <a:xfrm>
+            <a:off x="2331720" y="4059936"/>
+            <a:ext cx="2002536" cy="694944"/>
+          </a:xfrm>
+          <a:prstGeom prst="rect">
+            <a:avLst/>
+          </a:prstGeom>
+          <a:noFill/>
+        </p:spPr>
+        <p:txBody>
+          <a:bodyPr wrap="square" anchor="ctr"/>
+          <a:lstStyle/>
+          <a:p>
+            <a:pPr algn="l">
+              <a:spcBef>
+                <a:spcPts val="0"/>
+              </a:spcBef>
+              <a:spcAft>
+                <a:spcPts val="0"/>
+              </a:spcAft>
+            </a:pPr>
+            <a:r>
+              <a:rPr sz="1100" b="0">
+                <a:solidFill>
+                  <a:srgbClr val="111111"/>
+                </a:solidFill>
+                <a:latin typeface="PingFang SC"/>
+                <a:ea typeface="PingFang SC"/>
+              </a:rPr>
+              <a:t>两家跑通再开</a:t>
+            </a:r>
+          </a:p>
+          <a:p>
+            <a:pPr algn="l">
+              <a:spcBef>
+                <a:spcPts val="0"/>
+              </a:spcBef>
+              <a:spcAft>
+                <a:spcPts val="0"/>
+              </a:spcAft>
+            </a:pPr>
+            <a:r>
+              <a:rPr sz="1100" b="0">
+                <a:solidFill>
+                  <a:srgbClr val="111111"/>
+                </a:solidFill>
+                <a:latin typeface="PingFang SC"/>
+                <a:ea typeface="PingFang SC"/>
+              </a:rPr>
+              <a:t>可被搜到</a:t>
+            </a:r>
+          </a:p>
+        </p:txBody>
+      </p:sp>
+      <p:sp>
+        <p:nvSpPr>
+          <p:cNvPr id="50" name="Rectangle 49"/>
+          <p:cNvSpPr/>
+          <p:nvPr/>
+        </p:nvSpPr>
+        <p:spPr>
+          <a:xfrm>
+            <a:off x="4407408" y="4023360"/>
+            <a:ext cx="3063240" cy="749808"/>
+          </a:xfrm>
+          <a:prstGeom prst="rect">
+            <a:avLst/>
+          </a:prstGeom>
+          <a:solidFill>
+            <a:srgbClr val="FFFFFF"/>
+          </a:solidFill>
+          <a:ln w="9525">
+            <a:solidFill>
+              <a:srgbClr val="E6E6E6"/>
+            </a:solidFill>
+          </a:ln>
+          <a:effectLst/>
+        </p:spPr>
+        <p:style>
+          <a:lnRef idx="1">
+            <a:schemeClr val="accent1"/>
+          </a:lnRef>
+          <a:fillRef idx="3">
+            <a:schemeClr val="accent1"/>
+          </a:fillRef>
+          <a:effectRef idx="2">
+            <a:schemeClr val="accent1"/>
+          </a:effectRef>
+          <a:fontRef idx="minor">
+            <a:schemeClr val="lt1"/>
+          </a:fontRef>
+        </p:style>
+        <p:txBody>
+          <a:bodyPr rtlCol="0" anchor="ctr"/>
+          <a:lstStyle/>
+          <a:p>
+            <a:pPr algn="ctr"/>
+          </a:p>
+        </p:txBody>
+      </p:sp>
+      <p:sp>
+        <p:nvSpPr>
+          <p:cNvPr id="51" name="TextBox 50"/>
+          <p:cNvSpPr txBox="1"/>
+          <p:nvPr/>
+        </p:nvSpPr>
+        <p:spPr>
+          <a:xfrm>
+            <a:off x="4480560" y="4059936"/>
+            <a:ext cx="2916936" cy="694944"/>
+          </a:xfrm>
+          <a:prstGeom prst="rect">
+            <a:avLst/>
+          </a:prstGeom>
+          <a:noFill/>
+        </p:spPr>
+        <p:txBody>
+          <a:bodyPr wrap="square" anchor="ctr"/>
+          <a:lstStyle/>
+          <a:p>
+            <a:pPr algn="l">
+              <a:spcBef>
+                <a:spcPts val="0"/>
+              </a:spcBef>
+              <a:spcAft>
+                <a:spcPts val="0"/>
+              </a:spcAft>
+            </a:pPr>
+            <a:r>
+              <a:rPr sz="1100" b="0">
+                <a:solidFill>
+                  <a:srgbClr val="111111"/>
+                </a:solidFill>
+                <a:latin typeface="PingFang SC"/>
+                <a:ea typeface="PingFang SC"/>
+              </a:rPr>
+              <a:t>7 秒 SCORE + 60 秒系统片</a:t>
+            </a:r>
+          </a:p>
+          <a:p>
+            <a:pPr algn="l">
+              <a:spcBef>
+                <a:spcPts val="0"/>
+              </a:spcBef>
+              <a:spcAft>
+                <a:spcPts val="0"/>
+              </a:spcAft>
+            </a:pPr>
+            <a:r>
+              <a:rPr sz="1100" b="0">
+                <a:solidFill>
+                  <a:srgbClr val="111111"/>
+                </a:solidFill>
+                <a:latin typeface="PingFang SC"/>
+                <a:ea typeface="PingFang SC"/>
+              </a:rPr>
+              <a:t>+ 教程长视频。</a:t>
+            </a:r>
+          </a:p>
+        </p:txBody>
+      </p:sp>
+      <p:sp>
+        <p:nvSpPr>
+          <p:cNvPr id="52" name="Rectangle 51"/>
+          <p:cNvSpPr/>
+          <p:nvPr/>
+        </p:nvSpPr>
+        <p:spPr>
+          <a:xfrm>
+            <a:off x="7470648" y="4023360"/>
+            <a:ext cx="1965960" cy="749808"/>
+          </a:xfrm>
+          <a:prstGeom prst="rect">
+            <a:avLst/>
+          </a:prstGeom>
+          <a:solidFill>
+            <a:srgbClr val="FFFFFF"/>
+          </a:solidFill>
+          <a:ln w="9525">
+            <a:solidFill>
+              <a:srgbClr val="E6E6E6"/>
+            </a:solidFill>
+          </a:ln>
+          <a:effectLst/>
+        </p:spPr>
+        <p:style>
+          <a:lnRef idx="1">
+            <a:schemeClr val="accent1"/>
+          </a:lnRef>
+          <a:fillRef idx="3">
+            <a:schemeClr val="accent1"/>
+          </a:fillRef>
+          <a:effectRef idx="2">
+            <a:schemeClr val="accent1"/>
+          </a:effectRef>
+          <a:fontRef idx="minor">
+            <a:schemeClr val="lt1"/>
+          </a:fontRef>
+        </p:style>
+        <p:txBody>
+          <a:bodyPr rtlCol="0" anchor="ctr"/>
+          <a:lstStyle/>
+          <a:p>
+            <a:pPr algn="ctr"/>
+          </a:p>
+        </p:txBody>
+      </p:sp>
+      <p:sp>
+        <p:nvSpPr>
+          <p:cNvPr id="53" name="TextBox 52"/>
+          <p:cNvSpPr txBox="1"/>
+          <p:nvPr/>
+        </p:nvSpPr>
+        <p:spPr>
+          <a:xfrm>
+            <a:off x="7543800" y="4059936"/>
+            <a:ext cx="1819656" cy="694944"/>
+          </a:xfrm>
+          <a:prstGeom prst="rect">
+            <a:avLst/>
+          </a:prstGeom>
+          <a:noFill/>
+        </p:spPr>
+        <p:txBody>
+          <a:bodyPr wrap="square" anchor="ctr"/>
+          <a:lstStyle/>
+          <a:p>
+            <a:pPr algn="l">
+              <a:spcBef>
+                <a:spcPts val="0"/>
+              </a:spcBef>
+              <a:spcAft>
+                <a:spcPts val="0"/>
+              </a:spcAft>
+            </a:pPr>
+            <a:r>
+              <a:rPr sz="1100" b="0">
+                <a:solidFill>
+                  <a:srgbClr val="111111"/>
+                </a:solidFill>
+                <a:latin typeface="PingFang SC"/>
+                <a:ea typeface="PingFang SC"/>
+              </a:rPr>
+              <a:t>2 条/月</a:t>
+            </a:r>
+          </a:p>
+        </p:txBody>
+      </p:sp>
+      <p:sp>
+        <p:nvSpPr>
+          <p:cNvPr id="54" name="Rectangle 53"/>
+          <p:cNvSpPr/>
+          <p:nvPr/>
+        </p:nvSpPr>
+        <p:spPr>
+          <a:xfrm>
+            <a:off x="9436608" y="4023360"/>
+            <a:ext cx="2148840" cy="749808"/>
+          </a:xfrm>
+          <a:prstGeom prst="rect">
+            <a:avLst/>
+          </a:prstGeom>
+          <a:solidFill>
+            <a:srgbClr val="FFFFFF"/>
+          </a:solidFill>
+          <a:ln w="9525">
+            <a:solidFill>
+              <a:srgbClr val="E6E6E6"/>
+            </a:solidFill>
+          </a:ln>
+          <a:effectLst/>
+        </p:spPr>
+        <p:style>
+          <a:lnRef idx="1">
+            <a:schemeClr val="accent1"/>
+          </a:lnRef>
+          <a:fillRef idx="3">
+            <a:schemeClr val="accent1"/>
+          </a:fillRef>
+          <a:effectRef idx="2">
+            <a:schemeClr val="accent1"/>
+          </a:effectRef>
+          <a:fontRef idx="minor">
+            <a:schemeClr val="lt1"/>
+          </a:fontRef>
+        </p:style>
+        <p:txBody>
+          <a:bodyPr rtlCol="0" anchor="ctr"/>
+          <a:lstStyle/>
+          <a:p>
+            <a:pPr algn="ctr"/>
+          </a:p>
+        </p:txBody>
+      </p:sp>
+      <p:sp>
+        <p:nvSpPr>
+          <p:cNvPr id="55" name="TextBox 54"/>
+          <p:cNvSpPr txBox="1"/>
+          <p:nvPr/>
+        </p:nvSpPr>
+        <p:spPr>
+          <a:xfrm>
+            <a:off x="9509760" y="4059936"/>
+            <a:ext cx="2002536" cy="694944"/>
+          </a:xfrm>
+          <a:prstGeom prst="rect">
+            <a:avLst/>
+          </a:prstGeom>
+          <a:noFill/>
+        </p:spPr>
+        <p:txBody>
+          <a:bodyPr wrap="square" anchor="ctr"/>
+          <a:lstStyle/>
+          <a:p>
+            <a:pPr algn="l">
+              <a:spcBef>
+                <a:spcPts val="0"/>
+              </a:spcBef>
+              <a:spcAft>
+                <a:spcPts val="0"/>
+              </a:spcAft>
+            </a:pPr>
+            <a:r>
+              <a:rPr sz="1100" b="0">
+                <a:solidFill>
+                  <a:srgbClr val="111111"/>
+                </a:solidFill>
+                <a:latin typeface="PingFang SC"/>
+                <a:ea typeface="PingFang SC"/>
+              </a:rPr>
+              <a:t>Jürg</a:t>
+            </a:r>
+          </a:p>
+          <a:p>
+            <a:pPr algn="l">
+              <a:spcBef>
+                <a:spcPts val="0"/>
+              </a:spcBef>
+              <a:spcAft>
+                <a:spcPts val="0"/>
+              </a:spcAft>
+            </a:pPr>
+            <a:r>
+              <a:rPr sz="1100" b="0">
+                <a:solidFill>
+                  <a:srgbClr val="111111"/>
+                </a:solidFill>
+                <a:latin typeface="PingFang SC"/>
+                <a:ea typeface="PingFang SC"/>
+              </a:rPr>
+              <a:t>Donglin</a:t>
+            </a:r>
+          </a:p>
+        </p:txBody>
+      </p:sp>
+      <p:sp>
+        <p:nvSpPr>
+          <p:cNvPr id="56" name="Rectangle 55"/>
+          <p:cNvSpPr/>
+          <p:nvPr/>
+        </p:nvSpPr>
+        <p:spPr>
+          <a:xfrm>
+            <a:off x="566928" y="4919472"/>
             <a:ext cx="11045952" cy="658368"/>
           </a:xfrm>
           <a:prstGeom prst="rect">
@@ -18096,13 +19655,13 @@
       </p:sp>
       <p:sp>
         <p:nvSpPr>
-          <p:cNvPr id="47" name="TextBox 46"/>
-          <p:cNvSpPr txBox="1"/>
-          <p:nvPr/>
-        </p:nvSpPr>
-        <p:spPr>
-          <a:xfrm>
-            <a:off x="749808" y="5102352"/>
+          <p:cNvPr id="57" name="TextBox 56"/>
+          <p:cNvSpPr txBox="1"/>
+          <p:nvPr/>
+        </p:nvSpPr>
+        <p:spPr>
+          <a:xfrm>
+            <a:off x="749808" y="5010912"/>
             <a:ext cx="10698480" cy="475488"/>
           </a:xfrm>
           <a:prstGeom prst="rect">
@@ -18130,21 +19689,21 @@
                 <a:latin typeface="PingFang SC"/>
                 <a:ea typeface="PingFang SC"/>
               </a:rPr>
-              <a:t>三支片子循环用：A 60 秒系统片（10/20 交，用手球 intro 延伸）· B 30 秒 SCORE · C 30 秒 LED。官网、邮件、展会、经销商包同一套。</a:t>
-            </a:r>
-          </a:p>
-        </p:txBody>
-      </p:sp>
-      <p:sp>
-        <p:nvSpPr>
-          <p:cNvPr id="48" name="TextBox 47"/>
-          <p:cNvSpPr txBox="1"/>
-          <p:nvPr/>
-        </p:nvSpPr>
-        <p:spPr>
-          <a:xfrm>
-            <a:off x="566928" y="5779008"/>
-            <a:ext cx="11064240" cy="530352"/>
+              <a:t>注册：买一个全新瑞士手机号，账号不绑私人号。热点只蹭职业比赛夜和展会周，不蹭 iPhone 级消费发布会。</a:t>
+            </a:r>
+          </a:p>
+        </p:txBody>
+      </p:sp>
+      <p:sp>
+        <p:nvSpPr>
+          <p:cNvPr id="58" name="TextBox 57"/>
+          <p:cNvSpPr txBox="1"/>
+          <p:nvPr/>
+        </p:nvSpPr>
+        <p:spPr>
+          <a:xfrm>
+            <a:off x="566928" y="5687568"/>
+            <a:ext cx="11064240" cy="621792"/>
           </a:xfrm>
           <a:prstGeom prst="rect">
             <a:avLst/>
@@ -18171,14 +19730,14 @@
                 <a:latin typeface="PingFang SC"/>
                 <a:ea typeface="PingFang SC"/>
               </a:rPr>
-              <a:t>不做：TikTok、Pinterest、小红书对欧洲获客、Facebook 日常。账号可以占着，不排期、不考核。</a:t>
-            </a:r>
-          </a:p>
-        </p:txBody>
-      </p:sp>
-      <p:sp>
-        <p:nvSpPr>
-          <p:cNvPr id="49" name="TextBox 48"/>
+              <a:t>Facebook 只做竞品观察，不日常运营。TikTok / 小红书不对欧洲获客。文案可用 AI 起草，人必须改完再发。</a:t>
+            </a:r>
+          </a:p>
+        </p:txBody>
+      </p:sp>
+      <p:sp>
+        <p:nvSpPr>
+          <p:cNvPr id="59" name="TextBox 58"/>
           <p:cNvSpPr txBox="1"/>
           <p:nvPr/>
         </p:nvSpPr>
@@ -18219,7 +19778,7 @@
       </p:sp>
       <p:sp>
         <p:nvSpPr>
-          <p:cNvPr id="50" name="TextBox 49"/>
+          <p:cNvPr id="60" name="TextBox 59"/>
           <p:cNvSpPr txBox="1"/>
           <p:nvPr/>
         </p:nvSpPr>
@@ -18253,14 +19812,14 @@
                 <a:latin typeface="PingFang SC"/>
                 <a:ea typeface="PingFang SC"/>
               </a:rPr>
-              <a:t>6 / 11</a:t>
-            </a:r>
-          </a:p>
-        </p:txBody>
-      </p:sp>
-      <p:sp>
-        <p:nvSpPr>
-          <p:cNvPr id="51" name="Rectangle 50"/>
+              <a:t>6 / 12</a:t>
+            </a:r>
+          </a:p>
+        </p:txBody>
+      </p:sp>
+      <p:sp>
+        <p:nvSpPr>
+          <p:cNvPr id="61" name="Rectangle 60"/>
           <p:cNvSpPr/>
           <p:nvPr/>
         </p:nvSpPr>
@@ -19612,7 +21171,7 @@
                 <a:latin typeface="PingFang SC"/>
                 <a:ea typeface="PingFang SC"/>
               </a:rPr>
-              <a:t>7 / 11</a:t>
+              <a:t>7 / 12</a:t>
             </a:r>
           </a:p>
         </p:txBody>
@@ -20556,7 +22115,7 @@
                 <a:latin typeface="PingFang SC"/>
                 <a:ea typeface="PingFang SC"/>
               </a:rPr>
-              <a:t>8 / 11</a:t>
+              <a:t>8 / 12</a:t>
             </a:r>
           </a:p>
         </p:txBody>
@@ -24000,7 +25559,7 @@
                 <a:latin typeface="PingFang SC"/>
                 <a:ea typeface="PingFang SC"/>
               </a:rPr>
-              <a:t>9 / 11</a:t>
+              <a:t>9 / 12</a:t>
             </a:r>
           </a:p>
         </p:txBody>

</xml_diff>